<commit_message>
Minor updates since VM testing
</commit_message>
<xml_diff>
--- a/07_fMRI_Connectivity/07_02-03_fMRI_connectivity.pptx
+++ b/07_fMRI_Connectivity/07_02-03_fMRI_connectivity.pptx
@@ -297,7 +297,7 @@
               <a:pPr>
                 <a:defRPr/>
               </a:pPr>
-              <a:t>10/07/2026</a:t>
+              <a:t>26/07/2026</a:t>
             </a:fld>
             <a:endParaRPr lang="en-GB"/>
           </a:p>
@@ -7776,7 +7776,7 @@
               <a:pPr>
                 <a:defRPr/>
               </a:pPr>
-              <a:t>10/07/2026</a:t>
+              <a:t>26/07/2026</a:t>
             </a:fld>
             <a:endParaRPr lang="en-GB"/>
           </a:p>
@@ -8006,7 +8006,7 @@
               <a:pPr>
                 <a:defRPr/>
               </a:pPr>
-              <a:t>10/07/2026</a:t>
+              <a:t>26/07/2026</a:t>
             </a:fld>
             <a:endParaRPr lang="en-GB"/>
           </a:p>
@@ -8236,7 +8236,7 @@
               <a:pPr>
                 <a:defRPr/>
               </a:pPr>
-              <a:t>10/07/2026</a:t>
+              <a:t>26/07/2026</a:t>
             </a:fld>
             <a:endParaRPr lang="en-GB"/>
           </a:p>
@@ -8653,7 +8653,7 @@
               <a:pPr>
                 <a:defRPr/>
               </a:pPr>
-              <a:t>10/07/2026</a:t>
+              <a:t>26/07/2026</a:t>
             </a:fld>
             <a:endParaRPr lang="en-GB"/>
           </a:p>
@@ -8949,7 +8949,7 @@
               <a:pPr>
                 <a:defRPr/>
               </a:pPr>
-              <a:t>10/07/2026</a:t>
+              <a:t>26/07/2026</a:t>
             </a:fld>
             <a:endParaRPr lang="en-GB"/>
           </a:p>
@@ -9295,7 +9295,7 @@
               <a:pPr>
                 <a:defRPr/>
               </a:pPr>
-              <a:t>10/07/2026</a:t>
+              <a:t>26/07/2026</a:t>
             </a:fld>
             <a:endParaRPr lang="en-GB"/>
           </a:p>
@@ -9781,7 +9781,7 @@
               <a:pPr>
                 <a:defRPr/>
               </a:pPr>
-              <a:t>10/07/2026</a:t>
+              <a:t>26/07/2026</a:t>
             </a:fld>
             <a:endParaRPr lang="en-GB"/>
           </a:p>
@@ -9951,7 +9951,7 @@
               <a:pPr>
                 <a:defRPr/>
               </a:pPr>
-              <a:t>10/07/2026</a:t>
+              <a:t>26/07/2026</a:t>
             </a:fld>
             <a:endParaRPr lang="en-GB"/>
           </a:p>
@@ -10090,7 +10090,7 @@
               <a:pPr>
                 <a:defRPr/>
               </a:pPr>
-              <a:t>10/07/2026</a:t>
+              <a:t>26/07/2026</a:t>
             </a:fld>
             <a:endParaRPr lang="en-GB"/>
           </a:p>
@@ -10384,7 +10384,7 @@
               <a:pPr>
                 <a:defRPr/>
               </a:pPr>
-              <a:t>10/07/2026</a:t>
+              <a:t>26/07/2026</a:t>
             </a:fld>
             <a:endParaRPr lang="en-GB"/>
           </a:p>
@@ -10698,7 +10698,7 @@
               <a:pPr>
                 <a:defRPr/>
               </a:pPr>
-              <a:t>10/07/2026</a:t>
+              <a:t>26/07/2026</a:t>
             </a:fld>
             <a:endParaRPr lang="en-GB"/>
           </a:p>
@@ -10864,7 +10864,7 @@
               <a:pPr>
                 <a:defRPr/>
               </a:pPr>
-              <a:t>10/07/2026</a:t>
+              <a:t>26/07/2026</a:t>
             </a:fld>
             <a:endParaRPr lang="en-GB"/>
           </a:p>
@@ -36932,7 +36932,25 @@
               <a:rPr lang="de-CH" altLang="en-US" sz="1600" dirty="0">
                 <a:latin typeface="Arial Unicode MS" pitchFamily="34" charset="-128"/>
               </a:rPr>
-              <a:t>(whole-brain) decomposition, eg </a:t>
+              <a:t>(</a:t>
+            </a:r>
+            <a:r>
+              <a:rPr lang="de-CH" altLang="en-US" sz="1600" dirty="0" smtClean="0">
+                <a:latin typeface="Arial Unicode MS" pitchFamily="34" charset="-128"/>
+              </a:rPr>
+              <a:t>whole-brain, voxel-wise) </a:t>
+            </a:r>
+            <a:r>
+              <a:rPr lang="de-CH" altLang="en-US" sz="1600" dirty="0">
+                <a:latin typeface="Arial Unicode MS" pitchFamily="34" charset="-128"/>
+              </a:rPr>
+              <a:t>decomposition, </a:t>
+            </a:r>
+            <a:r>
+              <a:rPr lang="de-CH" altLang="en-US" sz="1600" dirty="0" smtClean="0">
+                <a:latin typeface="Arial Unicode MS" pitchFamily="34" charset="-128"/>
+              </a:rPr>
+              <a:t>eg PCA, </a:t>
             </a:r>
             <a:r>
               <a:rPr lang="de-CH" altLang="en-US" sz="1600" dirty="0" smtClean="0">
@@ -36951,10 +36969,16 @@
               </a:spcBef>
             </a:pPr>
             <a:r>
+              <a:rPr lang="de-CH" altLang="en-US" sz="1600" dirty="0" smtClean="0">
+                <a:latin typeface="Arial Unicode MS" pitchFamily="34" charset="-128"/>
+              </a:rPr>
+              <a:t>ROI(parcel)-based</a:t>
+            </a:r>
+            <a:r>
               <a:rPr lang="de-CH" altLang="en-US" sz="1600" dirty="0">
                 <a:latin typeface="Arial Unicode MS" pitchFamily="34" charset="-128"/>
               </a:rPr>
-              <a:t>ROI-based, pairwise connectivity </a:t>
+              <a:t>, pairwise connectivity </a:t>
             </a:r>
             <a:endParaRPr lang="de-CH" altLang="en-US" sz="1600" dirty="0" smtClean="0">
               <a:latin typeface="Arial Unicode MS" pitchFamily="34" charset="-128"/>
@@ -37008,7 +37032,13 @@
               <a:rPr lang="de-CH" altLang="en-US" sz="2000" dirty="0" smtClean="0">
                 <a:latin typeface="Arial Unicode MS" pitchFamily="34" charset="-128"/>
               </a:rPr>
-              <a:t>Network-based models</a:t>
+              <a:t>Network-based </a:t>
+            </a:r>
+            <a:r>
+              <a:rPr lang="de-CH" altLang="en-US" sz="2000" dirty="0" smtClean="0">
+                <a:latin typeface="Arial Unicode MS" pitchFamily="34" charset="-128"/>
+              </a:rPr>
+              <a:t>models</a:t>
             </a:r>
             <a:endParaRPr lang="de-CH" altLang="en-US" sz="2000" dirty="0">
               <a:latin typeface="Arial Unicode MS" pitchFamily="34" charset="-128"/>
@@ -37027,8 +37057,17 @@
               <a:rPr lang="de-CH" altLang="en-US" sz="1600" dirty="0" smtClean="0">
                 <a:latin typeface="Arial Unicode MS" pitchFamily="34" charset="-128"/>
               </a:rPr>
-              <a:t>Dynamic Causal Modelling (DCM) (Not covered in Notebooks)</a:t>
-            </a:r>
+              <a:t>Dynamic Causal Modelling (DCM) </a:t>
+            </a:r>
+            <a:r>
+              <a:rPr lang="de-CH" altLang="en-US" sz="1600" dirty="0" smtClean="0">
+                <a:latin typeface="Arial Unicode MS" pitchFamily="34" charset="-128"/>
+              </a:rPr>
+              <a:t>(effective connectivity; not covered in notebooks)</a:t>
+            </a:r>
+            <a:endParaRPr lang="de-CH" altLang="en-US" sz="1600" dirty="0" smtClean="0">
+              <a:latin typeface="Arial Unicode MS" pitchFamily="34" charset="-128"/>
+            </a:endParaRPr>
           </a:p>
           <a:p>
             <a:pPr lvl="1" eaLnBrk="1" hangingPunct="1">
@@ -37049,13 +37088,13 @@
               <a:rPr lang="de-CH" altLang="en-US" sz="1600" dirty="0">
                 <a:latin typeface="Arial Unicode MS" pitchFamily="34" charset="-128"/>
               </a:rPr>
-              <a:t>summaries of functional networks (see nb10 slides</a:t>
+              <a:t>summaries of functional </a:t>
             </a:r>
             <a:r>
               <a:rPr lang="de-CH" altLang="en-US" sz="1600" dirty="0" smtClean="0">
                 <a:latin typeface="Arial Unicode MS" pitchFamily="34" charset="-128"/>
               </a:rPr>
-              <a:t>)</a:t>
+              <a:t>networks</a:t>
             </a:r>
             <a:endParaRPr lang="de-CH" altLang="en-US" sz="1600" dirty="0">
               <a:latin typeface="Arial Unicode MS" pitchFamily="34" charset="-128"/>
@@ -37168,15 +37207,33 @@
                                   </p:childTnLst>
                                 </p:cTn>
                               </p:par>
+                            </p:childTnLst>
+                          </p:cTn>
+                        </p:par>
+                      </p:childTnLst>
+                    </p:cTn>
+                  </p:par>
+                  <p:par>
+                    <p:cTn id="7" fill="hold">
+                      <p:stCondLst>
+                        <p:cond delay="indefinite"/>
+                      </p:stCondLst>
+                      <p:childTnLst>
+                        <p:par>
+                          <p:cTn id="8" fill="hold">
+                            <p:stCondLst>
+                              <p:cond delay="0"/>
+                            </p:stCondLst>
+                            <p:childTnLst>
                               <p:par>
-                                <p:cTn id="7" presetID="1" presetClass="entr" presetSubtype="0" fill="hold" grpId="0" nodeType="withEffect">
+                                <p:cTn id="9" presetID="1" presetClass="entr" presetSubtype="0" fill="hold" grpId="0" nodeType="clickEffect">
                                   <p:stCondLst>
                                     <p:cond delay="0"/>
                                   </p:stCondLst>
                                   <p:childTnLst>
                                     <p:set>
                                       <p:cBhvr>
-                                        <p:cTn id="8" dur="1" fill="hold">
+                                        <p:cTn id="10" dur="1" fill="hold">
                                           <p:stCondLst>
                                             <p:cond delay="0"/>
                                           </p:stCondLst>
@@ -37199,15 +37256,33 @@
                                   </p:childTnLst>
                                 </p:cTn>
                               </p:par>
+                            </p:childTnLst>
+                          </p:cTn>
+                        </p:par>
+                      </p:childTnLst>
+                    </p:cTn>
+                  </p:par>
+                  <p:par>
+                    <p:cTn id="11" fill="hold">
+                      <p:stCondLst>
+                        <p:cond delay="indefinite"/>
+                      </p:stCondLst>
+                      <p:childTnLst>
+                        <p:par>
+                          <p:cTn id="12" fill="hold">
+                            <p:stCondLst>
+                              <p:cond delay="0"/>
+                            </p:stCondLst>
+                            <p:childTnLst>
                               <p:par>
-                                <p:cTn id="9" presetID="1" presetClass="entr" presetSubtype="0" fill="hold" grpId="0" nodeType="withEffect">
+                                <p:cTn id="13" presetID="1" presetClass="entr" presetSubtype="0" fill="hold" grpId="0" nodeType="clickEffect">
                                   <p:stCondLst>
                                     <p:cond delay="0"/>
                                   </p:stCondLst>
                                   <p:childTnLst>
                                     <p:set>
                                       <p:cBhvr>
-                                        <p:cTn id="10" dur="1" fill="hold">
+                                        <p:cTn id="14" dur="1" fill="hold">
                                           <p:stCondLst>
                                             <p:cond delay="0"/>
                                           </p:stCondLst>
@@ -37230,37 +37305,6 @@
                                   </p:childTnLst>
                                 </p:cTn>
                               </p:par>
-                              <p:par>
-                                <p:cTn id="11" presetID="1" presetClass="entr" presetSubtype="0" fill="hold" grpId="0" nodeType="withEffect">
-                                  <p:stCondLst>
-                                    <p:cond delay="0"/>
-                                  </p:stCondLst>
-                                  <p:childTnLst>
-                                    <p:set>
-                                      <p:cBhvr>
-                                        <p:cTn id="12" dur="1" fill="hold">
-                                          <p:stCondLst>
-                                            <p:cond delay="0"/>
-                                          </p:stCondLst>
-                                        </p:cTn>
-                                        <p:tgtEl>
-                                          <p:spTgt spid="175106">
-                                            <p:txEl>
-                                              <p:pRg st="3" end="3"/>
-                                            </p:txEl>
-                                          </p:spTgt>
-                                        </p:tgtEl>
-                                        <p:attrNameLst>
-                                          <p:attrName>style.visibility</p:attrName>
-                                        </p:attrNameLst>
-                                      </p:cBhvr>
-                                      <p:to>
-                                        <p:strVal val="visible"/>
-                                      </p:to>
-                                    </p:set>
-                                  </p:childTnLst>
-                                </p:cTn>
-                              </p:par>
                             </p:childTnLst>
                           </p:cTn>
                         </p:par>
@@ -37268,50 +37312,19 @@
                     </p:cTn>
                   </p:par>
                   <p:par>
-                    <p:cTn id="13" fill="hold">
+                    <p:cTn id="15" fill="hold">
                       <p:stCondLst>
                         <p:cond delay="indefinite"/>
                       </p:stCondLst>
                       <p:childTnLst>
                         <p:par>
-                          <p:cTn id="14" fill="hold">
+                          <p:cTn id="16" fill="hold">
                             <p:stCondLst>
                               <p:cond delay="0"/>
                             </p:stCondLst>
                             <p:childTnLst>
                               <p:par>
-                                <p:cTn id="15" presetID="1" presetClass="entr" presetSubtype="0" fill="hold" grpId="0" nodeType="clickEffect">
-                                  <p:stCondLst>
-                                    <p:cond delay="0"/>
-                                  </p:stCondLst>
-                                  <p:childTnLst>
-                                    <p:set>
-                                      <p:cBhvr>
-                                        <p:cTn id="16" dur="1" fill="hold">
-                                          <p:stCondLst>
-                                            <p:cond delay="0"/>
-                                          </p:stCondLst>
-                                        </p:cTn>
-                                        <p:tgtEl>
-                                          <p:spTgt spid="175106">
-                                            <p:txEl>
-                                              <p:pRg st="4" end="4"/>
-                                            </p:txEl>
-                                          </p:spTgt>
-                                        </p:tgtEl>
-                                        <p:attrNameLst>
-                                          <p:attrName>style.visibility</p:attrName>
-                                        </p:attrNameLst>
-                                      </p:cBhvr>
-                                      <p:to>
-                                        <p:strVal val="visible"/>
-                                      </p:to>
-                                    </p:set>
-                                  </p:childTnLst>
-                                </p:cTn>
-                              </p:par>
-                              <p:par>
-                                <p:cTn id="17" presetID="1" presetClass="entr" presetSubtype="0" fill="hold" grpId="0" nodeType="withEffect">
+                                <p:cTn id="17" presetID="1" presetClass="entr" presetSubtype="0" fill="hold" grpId="0" nodeType="clickEffect">
                                   <p:stCondLst>
                                     <p:cond delay="0"/>
                                   </p:stCondLst>
@@ -37326,7 +37339,7 @@
                                         <p:tgtEl>
                                           <p:spTgt spid="175106">
                                             <p:txEl>
-                                              <p:pRg st="5" end="5"/>
+                                              <p:pRg st="3" end="3"/>
                                             </p:txEl>
                                           </p:spTgt>
                                         </p:tgtEl>
@@ -37375,7 +37388,7 @@
                                         <p:tgtEl>
                                           <p:spTgt spid="175106">
                                             <p:txEl>
-                                              <p:pRg st="6" end="6"/>
+                                              <p:pRg st="4" end="4"/>
                                             </p:txEl>
                                           </p:spTgt>
                                         </p:tgtEl>
@@ -37424,7 +37437,7 @@
                                         <p:tgtEl>
                                           <p:spTgt spid="175106">
                                             <p:txEl>
-                                              <p:pRg st="7" end="7"/>
+                                              <p:pRg st="5" end="5"/>
                                             </p:txEl>
                                           </p:spTgt>
                                         </p:tgtEl>
@@ -37466,6 +37479,104 @@
                                     <p:set>
                                       <p:cBhvr>
                                         <p:cTn id="30" dur="1" fill="hold">
+                                          <p:stCondLst>
+                                            <p:cond delay="0"/>
+                                          </p:stCondLst>
+                                        </p:cTn>
+                                        <p:tgtEl>
+                                          <p:spTgt spid="175106">
+                                            <p:txEl>
+                                              <p:pRg st="6" end="6"/>
+                                            </p:txEl>
+                                          </p:spTgt>
+                                        </p:tgtEl>
+                                        <p:attrNameLst>
+                                          <p:attrName>style.visibility</p:attrName>
+                                        </p:attrNameLst>
+                                      </p:cBhvr>
+                                      <p:to>
+                                        <p:strVal val="visible"/>
+                                      </p:to>
+                                    </p:set>
+                                  </p:childTnLst>
+                                </p:cTn>
+                              </p:par>
+                            </p:childTnLst>
+                          </p:cTn>
+                        </p:par>
+                      </p:childTnLst>
+                    </p:cTn>
+                  </p:par>
+                  <p:par>
+                    <p:cTn id="31" fill="hold">
+                      <p:stCondLst>
+                        <p:cond delay="indefinite"/>
+                      </p:stCondLst>
+                      <p:childTnLst>
+                        <p:par>
+                          <p:cTn id="32" fill="hold">
+                            <p:stCondLst>
+                              <p:cond delay="0"/>
+                            </p:stCondLst>
+                            <p:childTnLst>
+                              <p:par>
+                                <p:cTn id="33" presetID="1" presetClass="entr" presetSubtype="0" fill="hold" grpId="0" nodeType="clickEffect">
+                                  <p:stCondLst>
+                                    <p:cond delay="0"/>
+                                  </p:stCondLst>
+                                  <p:childTnLst>
+                                    <p:set>
+                                      <p:cBhvr>
+                                        <p:cTn id="34" dur="1" fill="hold">
+                                          <p:stCondLst>
+                                            <p:cond delay="0"/>
+                                          </p:stCondLst>
+                                        </p:cTn>
+                                        <p:tgtEl>
+                                          <p:spTgt spid="175106">
+                                            <p:txEl>
+                                              <p:pRg st="7" end="7"/>
+                                            </p:txEl>
+                                          </p:spTgt>
+                                        </p:tgtEl>
+                                        <p:attrNameLst>
+                                          <p:attrName>style.visibility</p:attrName>
+                                        </p:attrNameLst>
+                                      </p:cBhvr>
+                                      <p:to>
+                                        <p:strVal val="visible"/>
+                                      </p:to>
+                                    </p:set>
+                                  </p:childTnLst>
+                                </p:cTn>
+                              </p:par>
+                            </p:childTnLst>
+                          </p:cTn>
+                        </p:par>
+                      </p:childTnLst>
+                    </p:cTn>
+                  </p:par>
+                  <p:par>
+                    <p:cTn id="35" fill="hold">
+                      <p:stCondLst>
+                        <p:cond delay="indefinite"/>
+                      </p:stCondLst>
+                      <p:childTnLst>
+                        <p:par>
+                          <p:cTn id="36" fill="hold">
+                            <p:stCondLst>
+                              <p:cond delay="0"/>
+                            </p:stCondLst>
+                            <p:childTnLst>
+                              <p:par>
+                                <p:cTn id="37" presetID="1" presetClass="entr" presetSubtype="0" fill="hold" grpId="0" nodeType="clickEffect">
+                                  <p:stCondLst>
+                                    <p:cond delay="0"/>
+                                  </p:stCondLst>
+                                  <p:childTnLst>
+                                    <p:set>
+                                      <p:cBhvr>
+                                        <p:cTn id="38" dur="1" fill="hold">
                                           <p:stCondLst>
                                             <p:cond delay="0"/>
                                           </p:stCondLst>

</xml_diff>